<commit_message>
Embed logos in PPTX export (jsdelivr/vectorlogo CDN cache)
Co-authored-by: Emilio Gorky <egorky@users.noreply.github.com>
</commit_message>
<xml_diff>
--- a/slides/Transformacion_Digital_Soporte_Inteligente_Sempitecno.pptx
+++ b/slides/Transformacion_Digital_Soporte_Inteligente_Sempitecno.pptx
@@ -3383,9 +3383,33 @@
           </a:p>
         </p:txBody>
       </p:sp>
-      <p:sp>
-        <p:nvSpPr>
-          <p:cNvPr id="5" name="Rounded Rectangle 4"/>
+      <p:pic>
+        <p:nvPicPr>
+          <p:cNvPr id="5" name="Picture 4" descr="otobo.png"/>
+          <p:cNvPicPr>
+            <a:picLocks noChangeAspect="1"/>
+          </p:cNvPicPr>
+          <p:nvPr/>
+        </p:nvPicPr>
+        <p:blipFill>
+          <a:blip r:embed="rId2"/>
+          <a:stretch>
+            <a:fillRect/>
+          </a:stretch>
+        </p:blipFill>
+        <p:spPr>
+          <a:xfrm>
+            <a:off x="5410047" y="1417320"/>
+            <a:ext cx="1760220" cy="502920"/>
+          </a:xfrm>
+          <a:prstGeom prst="rect">
+            <a:avLst/>
+          </a:prstGeom>
+        </p:spPr>
+      </p:pic>
+      <p:sp>
+        <p:nvSpPr>
+          <p:cNvPr id="6" name="Rounded Rectangle 5"/>
           <p:cNvSpPr/>
           <p:nvPr/>
         </p:nvSpPr>
@@ -3430,7 +3454,7 @@
       </p:sp>
       <p:sp>
         <p:nvSpPr>
-          <p:cNvPr id="6" name="Rectangle 5"/>
+          <p:cNvPr id="7" name="Rectangle 6"/>
           <p:cNvSpPr/>
           <p:nvPr/>
         </p:nvSpPr>
@@ -3473,7 +3497,7 @@
       </p:sp>
       <p:sp>
         <p:nvSpPr>
-          <p:cNvPr id="7" name="TextBox 6"/>
+          <p:cNvPr id="8" name="TextBox 7"/>
           <p:cNvSpPr txBox="1"/>
           <p:nvPr/>
         </p:nvSpPr>
@@ -3520,7 +3544,7 @@
       </p:sp>
       <p:sp>
         <p:nvSpPr>
-          <p:cNvPr id="8" name="Rounded Rectangle 7"/>
+          <p:cNvPr id="9" name="Rounded Rectangle 8"/>
           <p:cNvSpPr/>
           <p:nvPr/>
         </p:nvSpPr>
@@ -3565,7 +3589,7 @@
       </p:sp>
       <p:sp>
         <p:nvSpPr>
-          <p:cNvPr id="9" name="Rectangle 8"/>
+          <p:cNvPr id="10" name="Rectangle 9"/>
           <p:cNvSpPr/>
           <p:nvPr/>
         </p:nvSpPr>
@@ -3608,7 +3632,7 @@
       </p:sp>
       <p:sp>
         <p:nvSpPr>
-          <p:cNvPr id="10" name="TextBox 9"/>
+          <p:cNvPr id="11" name="TextBox 10"/>
           <p:cNvSpPr txBox="1"/>
           <p:nvPr/>
         </p:nvSpPr>
@@ -3655,7 +3679,7 @@
       </p:sp>
       <p:sp>
         <p:nvSpPr>
-          <p:cNvPr id="11" name="Rounded Rectangle 10"/>
+          <p:cNvPr id="12" name="Rounded Rectangle 11"/>
           <p:cNvSpPr/>
           <p:nvPr/>
         </p:nvSpPr>
@@ -3700,7 +3724,7 @@
       </p:sp>
       <p:sp>
         <p:nvSpPr>
-          <p:cNvPr id="12" name="Rectangle 11"/>
+          <p:cNvPr id="13" name="Rectangle 12"/>
           <p:cNvSpPr/>
           <p:nvPr/>
         </p:nvSpPr>
@@ -3743,7 +3767,7 @@
       </p:sp>
       <p:sp>
         <p:nvSpPr>
-          <p:cNvPr id="13" name="TextBox 12"/>
+          <p:cNvPr id="14" name="TextBox 13"/>
           <p:cNvSpPr txBox="1"/>
           <p:nvPr/>
         </p:nvSpPr>
@@ -3968,9 +3992,33 @@
           </a:p>
         </p:txBody>
       </p:sp>
-      <p:sp>
-        <p:nvSpPr>
-          <p:cNvPr id="6" name="TextBox 5"/>
+      <p:pic>
+        <p:nvPicPr>
+          <p:cNvPr id="6" name="Picture 5" descr="issabel.png"/>
+          <p:cNvPicPr>
+            <a:picLocks noChangeAspect="1"/>
+          </p:cNvPicPr>
+          <p:nvPr/>
+        </p:nvPicPr>
+        <p:blipFill>
+          <a:blip r:embed="rId2"/>
+          <a:stretch>
+            <a:fillRect/>
+          </a:stretch>
+        </p:blipFill>
+        <p:spPr>
+          <a:xfrm>
+            <a:off x="5410047" y="1828800"/>
+            <a:ext cx="1760220" cy="502920"/>
+          </a:xfrm>
+          <a:prstGeom prst="rect">
+            <a:avLst/>
+          </a:prstGeom>
+        </p:spPr>
+      </p:pic>
+      <p:sp>
+        <p:nvSpPr>
+          <p:cNvPr id="7" name="TextBox 6"/>
           <p:cNvSpPr txBox="1"/>
           <p:nvPr/>
         </p:nvSpPr>
@@ -4181,9 +4229,33 @@
           </a:p>
         </p:txBody>
       </p:sp>
-      <p:sp>
-        <p:nvSpPr>
-          <p:cNvPr id="5" name="Rounded Rectangle 4"/>
+      <p:pic>
+        <p:nvPicPr>
+          <p:cNvPr id="5" name="Picture 4" descr="issabel.png"/>
+          <p:cNvPicPr>
+            <a:picLocks noChangeAspect="1"/>
+          </p:cNvPicPr>
+          <p:nvPr/>
+        </p:nvPicPr>
+        <p:blipFill>
+          <a:blip r:embed="rId2"/>
+          <a:stretch>
+            <a:fillRect/>
+          </a:stretch>
+        </p:blipFill>
+        <p:spPr>
+          <a:xfrm>
+            <a:off x="5410047" y="1417320"/>
+            <a:ext cx="1760220" cy="502920"/>
+          </a:xfrm>
+          <a:prstGeom prst="rect">
+            <a:avLst/>
+          </a:prstGeom>
+        </p:spPr>
+      </p:pic>
+      <p:sp>
+        <p:nvSpPr>
+          <p:cNvPr id="6" name="Rounded Rectangle 5"/>
           <p:cNvSpPr/>
           <p:nvPr/>
         </p:nvSpPr>
@@ -4228,7 +4300,7 @@
       </p:sp>
       <p:sp>
         <p:nvSpPr>
-          <p:cNvPr id="6" name="Rectangle 5"/>
+          <p:cNvPr id="7" name="Rectangle 6"/>
           <p:cNvSpPr/>
           <p:nvPr/>
         </p:nvSpPr>
@@ -4271,7 +4343,7 @@
       </p:sp>
       <p:sp>
         <p:nvSpPr>
-          <p:cNvPr id="7" name="TextBox 6"/>
+          <p:cNvPr id="8" name="TextBox 7"/>
           <p:cNvSpPr txBox="1"/>
           <p:nvPr/>
         </p:nvSpPr>
@@ -4318,7 +4390,7 @@
       </p:sp>
       <p:sp>
         <p:nvSpPr>
-          <p:cNvPr id="8" name="Rounded Rectangle 7"/>
+          <p:cNvPr id="9" name="Rounded Rectangle 8"/>
           <p:cNvSpPr/>
           <p:nvPr/>
         </p:nvSpPr>
@@ -4363,7 +4435,7 @@
       </p:sp>
       <p:sp>
         <p:nvSpPr>
-          <p:cNvPr id="9" name="Rectangle 8"/>
+          <p:cNvPr id="10" name="Rectangle 9"/>
           <p:cNvSpPr/>
           <p:nvPr/>
         </p:nvSpPr>
@@ -4406,7 +4478,7 @@
       </p:sp>
       <p:sp>
         <p:nvSpPr>
-          <p:cNvPr id="10" name="TextBox 9"/>
+          <p:cNvPr id="11" name="TextBox 10"/>
           <p:cNvSpPr txBox="1"/>
           <p:nvPr/>
         </p:nvSpPr>
@@ -4453,7 +4525,7 @@
       </p:sp>
       <p:sp>
         <p:nvSpPr>
-          <p:cNvPr id="11" name="Rounded Rectangle 10"/>
+          <p:cNvPr id="12" name="Rounded Rectangle 11"/>
           <p:cNvSpPr/>
           <p:nvPr/>
         </p:nvSpPr>
@@ -4498,7 +4570,7 @@
       </p:sp>
       <p:sp>
         <p:nvSpPr>
-          <p:cNvPr id="12" name="Rectangle 11"/>
+          <p:cNvPr id="13" name="Rectangle 12"/>
           <p:cNvSpPr/>
           <p:nvPr/>
         </p:nvSpPr>
@@ -4541,7 +4613,7 @@
       </p:sp>
       <p:sp>
         <p:nvSpPr>
-          <p:cNvPr id="13" name="TextBox 12"/>
+          <p:cNvPr id="14" name="TextBox 13"/>
           <p:cNvSpPr txBox="1"/>
           <p:nvPr/>
         </p:nvSpPr>
@@ -4897,9 +4969,33 @@
           </a:p>
         </p:txBody>
       </p:sp>
-      <p:sp>
-        <p:nvSpPr>
-          <p:cNvPr id="6" name="TextBox 5"/>
+      <p:pic>
+        <p:nvPicPr>
+          <p:cNvPr id="6" name="Picture 5" descr="openai.png"/>
+          <p:cNvPicPr>
+            <a:picLocks noChangeAspect="1"/>
+          </p:cNvPicPr>
+          <p:nvPr/>
+        </p:nvPicPr>
+        <p:blipFill>
+          <a:blip r:embed="rId2"/>
+          <a:stretch>
+            <a:fillRect/>
+          </a:stretch>
+        </p:blipFill>
+        <p:spPr>
+          <a:xfrm>
+            <a:off x="5410047" y="1828800"/>
+            <a:ext cx="502920" cy="502920"/>
+          </a:xfrm>
+          <a:prstGeom prst="rect">
+            <a:avLst/>
+          </a:prstGeom>
+        </p:spPr>
+      </p:pic>
+      <p:sp>
+        <p:nvSpPr>
+          <p:cNvPr id="7" name="TextBox 6"/>
           <p:cNvSpPr txBox="1"/>
           <p:nvPr/>
         </p:nvSpPr>
@@ -4934,7 +5030,7 @@
       </p:sp>
       <p:sp>
         <p:nvSpPr>
-          <p:cNvPr id="7" name="Rounded Rectangle 6"/>
+          <p:cNvPr id="8" name="Rounded Rectangle 7"/>
           <p:cNvSpPr/>
           <p:nvPr/>
         </p:nvSpPr>
@@ -4986,7 +5082,7 @@
       </p:sp>
       <p:sp>
         <p:nvSpPr>
-          <p:cNvPr id="8" name="Rounded Rectangle 7"/>
+          <p:cNvPr id="9" name="Rounded Rectangle 8"/>
           <p:cNvSpPr/>
           <p:nvPr/>
         </p:nvSpPr>
@@ -5038,7 +5134,7 @@
       </p:sp>
       <p:sp>
         <p:nvSpPr>
-          <p:cNvPr id="9" name="Rounded Rectangle 8"/>
+          <p:cNvPr id="10" name="Rounded Rectangle 9"/>
           <p:cNvSpPr/>
           <p:nvPr/>
         </p:nvSpPr>
@@ -5088,6 +5184,30 @@
           </a:p>
         </p:txBody>
       </p:sp>
+      <p:pic>
+        <p:nvPicPr>
+          <p:cNvPr id="11" name="Picture 10" descr="openai.png"/>
+          <p:cNvPicPr>
+            <a:picLocks noChangeAspect="1"/>
+          </p:cNvPicPr>
+          <p:nvPr/>
+        </p:nvPicPr>
+        <p:blipFill>
+          <a:blip r:embed="rId2"/>
+          <a:stretch>
+            <a:fillRect/>
+          </a:stretch>
+        </p:blipFill>
+        <p:spPr>
+          <a:xfrm>
+            <a:off x="5410047" y="4572000"/>
+            <a:ext cx="502920" cy="502920"/>
+          </a:xfrm>
+          <a:prstGeom prst="rect">
+            <a:avLst/>
+          </a:prstGeom>
+        </p:spPr>
+      </p:pic>
     </p:spTree>
   </p:cSld>
   <p:clrMapOvr>
@@ -5320,9 +5440,81 @@
           </a:p>
         </p:txBody>
       </p:sp>
-      <p:sp>
-        <p:nvSpPr>
-          <p:cNvPr id="7" name="TextBox 6"/>
+      <p:pic>
+        <p:nvPicPr>
+          <p:cNvPr id="7" name="Picture 6" descr="whatsapp.png"/>
+          <p:cNvPicPr>
+            <a:picLocks noChangeAspect="1"/>
+          </p:cNvPicPr>
+          <p:nvPr/>
+        </p:nvPicPr>
+        <p:blipFill>
+          <a:blip r:embed="rId2"/>
+          <a:stretch>
+            <a:fillRect/>
+          </a:stretch>
+        </p:blipFill>
+        <p:spPr>
+          <a:xfrm>
+            <a:off x="3764127" y="1828800"/>
+            <a:ext cx="502920" cy="502920"/>
+          </a:xfrm>
+          <a:prstGeom prst="rect">
+            <a:avLst/>
+          </a:prstGeom>
+        </p:spPr>
+      </p:pic>
+      <p:pic>
+        <p:nvPicPr>
+          <p:cNvPr id="8" name="Picture 7" descr="telegram.png"/>
+          <p:cNvPicPr>
+            <a:picLocks noChangeAspect="1"/>
+          </p:cNvPicPr>
+          <p:nvPr/>
+        </p:nvPicPr>
+        <p:blipFill>
+          <a:blip r:embed="rId3"/>
+          <a:stretch>
+            <a:fillRect/>
+          </a:stretch>
+        </p:blipFill>
+        <p:spPr>
+          <a:xfrm>
+            <a:off x="5410047" y="1828800"/>
+            <a:ext cx="502920" cy="502920"/>
+          </a:xfrm>
+          <a:prstGeom prst="rect">
+            <a:avLst/>
+          </a:prstGeom>
+        </p:spPr>
+      </p:pic>
+      <p:pic>
+        <p:nvPicPr>
+          <p:cNvPr id="9" name="Picture 8" descr="openai.png"/>
+          <p:cNvPicPr>
+            <a:picLocks noChangeAspect="1"/>
+          </p:cNvPicPr>
+          <p:nvPr/>
+        </p:nvPicPr>
+        <p:blipFill>
+          <a:blip r:embed="rId4"/>
+          <a:stretch>
+            <a:fillRect/>
+          </a:stretch>
+        </p:blipFill>
+        <p:spPr>
+          <a:xfrm>
+            <a:off x="7055967" y="1828800"/>
+            <a:ext cx="502920" cy="502920"/>
+          </a:xfrm>
+          <a:prstGeom prst="rect">
+            <a:avLst/>
+          </a:prstGeom>
+        </p:spPr>
+      </p:pic>
+      <p:sp>
+        <p:nvSpPr>
+          <p:cNvPr id="10" name="TextBox 9"/>
           <p:cNvSpPr txBox="1"/>
           <p:nvPr/>
         </p:nvSpPr>
@@ -5652,7 +5844,7 @@
       </p:sp>
       <p:pic>
         <p:nvPicPr>
-          <p:cNvPr id="7" name="Picture 6" descr="glpi.png"/>
+          <p:cNvPr id="7" name="Picture 6" descr="zabbix.png"/>
           <p:cNvPicPr>
             <a:picLocks noChangeAspect="1"/>
           </p:cNvPicPr>
@@ -5666,6 +5858,30 @@
         </p:blipFill>
         <p:spPr>
           <a:xfrm>
+            <a:off x="3764127" y="1828800"/>
+            <a:ext cx="1005840" cy="502920"/>
+          </a:xfrm>
+          <a:prstGeom prst="rect">
+            <a:avLst/>
+          </a:prstGeom>
+        </p:spPr>
+      </p:pic>
+      <p:pic>
+        <p:nvPicPr>
+          <p:cNvPr id="8" name="Picture 7" descr="glpi.png"/>
+          <p:cNvPicPr>
+            <a:picLocks noChangeAspect="1"/>
+          </p:cNvPicPr>
+          <p:nvPr/>
+        </p:nvPicPr>
+        <p:blipFill>
+          <a:blip r:embed="rId3"/>
+          <a:stretch>
+            <a:fillRect/>
+          </a:stretch>
+        </p:blipFill>
+        <p:spPr>
+          <a:xfrm>
             <a:off x="5410047" y="1828800"/>
             <a:ext cx="911087" cy="502920"/>
           </a:xfrm>
@@ -5674,9 +5890,33 @@
           </a:prstGeom>
         </p:spPr>
       </p:pic>
-      <p:sp>
-        <p:nvSpPr>
-          <p:cNvPr id="8" name="TextBox 7"/>
+      <p:pic>
+        <p:nvPicPr>
+          <p:cNvPr id="9" name="Picture 8" descr="otobo.png"/>
+          <p:cNvPicPr>
+            <a:picLocks noChangeAspect="1"/>
+          </p:cNvPicPr>
+          <p:nvPr/>
+        </p:nvPicPr>
+        <p:blipFill>
+          <a:blip r:embed="rId4"/>
+          <a:stretch>
+            <a:fillRect/>
+          </a:stretch>
+        </p:blipFill>
+        <p:spPr>
+          <a:xfrm>
+            <a:off x="7055967" y="1828800"/>
+            <a:ext cx="1760220" cy="502920"/>
+          </a:xfrm>
+          <a:prstGeom prst="rect">
+            <a:avLst/>
+          </a:prstGeom>
+        </p:spPr>
+      </p:pic>
+      <p:sp>
+        <p:nvSpPr>
+          <p:cNvPr id="10" name="TextBox 9"/>
           <p:cNvSpPr txBox="1"/>
           <p:nvPr/>
         </p:nvSpPr>
@@ -7066,7 +7306,7 @@
       </p:sp>
       <p:pic>
         <p:nvPicPr>
-          <p:cNvPr id="5" name="Picture 4" descr="glpi.png"/>
+          <p:cNvPr id="5" name="Picture 4" descr="zabbix.png"/>
           <p:cNvPicPr>
             <a:picLocks noChangeAspect="1"/>
           </p:cNvPicPr>
@@ -7080,7 +7320,55 @@
         </p:blipFill>
         <p:spPr>
           <a:xfrm>
+            <a:off x="3764127" y="1417320"/>
+            <a:ext cx="1005840" cy="502920"/>
+          </a:xfrm>
+          <a:prstGeom prst="rect">
+            <a:avLst/>
+          </a:prstGeom>
+        </p:spPr>
+      </p:pic>
+      <p:pic>
+        <p:nvPicPr>
+          <p:cNvPr id="6" name="Picture 5" descr="openai.png"/>
+          <p:cNvPicPr>
+            <a:picLocks noChangeAspect="1"/>
+          </p:cNvPicPr>
+          <p:nvPr/>
+        </p:nvPicPr>
+        <p:blipFill>
+          <a:blip r:embed="rId3"/>
+          <a:stretch>
+            <a:fillRect/>
+          </a:stretch>
+        </p:blipFill>
+        <p:spPr>
+          <a:xfrm>
             <a:off x="5410047" y="1417320"/>
+            <a:ext cx="502920" cy="502920"/>
+          </a:xfrm>
+          <a:prstGeom prst="rect">
+            <a:avLst/>
+          </a:prstGeom>
+        </p:spPr>
+      </p:pic>
+      <p:pic>
+        <p:nvPicPr>
+          <p:cNvPr id="7" name="Picture 6" descr="glpi.png"/>
+          <p:cNvPicPr>
+            <a:picLocks noChangeAspect="1"/>
+          </p:cNvPicPr>
+          <p:nvPr/>
+        </p:nvPicPr>
+        <p:blipFill>
+          <a:blip r:embed="rId4"/>
+          <a:stretch>
+            <a:fillRect/>
+          </a:stretch>
+        </p:blipFill>
+        <p:spPr>
+          <a:xfrm>
+            <a:off x="7055967" y="1417320"/>
             <a:ext cx="911087" cy="502920"/>
           </a:xfrm>
           <a:prstGeom prst="rect">
@@ -7090,7 +7378,7 @@
       </p:pic>
       <p:sp>
         <p:nvSpPr>
-          <p:cNvPr id="6" name="Rounded Rectangle 5"/>
+          <p:cNvPr id="8" name="Rounded Rectangle 7"/>
           <p:cNvSpPr/>
           <p:nvPr/>
         </p:nvSpPr>
@@ -7135,7 +7423,7 @@
       </p:sp>
       <p:sp>
         <p:nvSpPr>
-          <p:cNvPr id="7" name="Rectangle 6"/>
+          <p:cNvPr id="9" name="Rectangle 8"/>
           <p:cNvSpPr/>
           <p:nvPr/>
         </p:nvSpPr>
@@ -7178,7 +7466,7 @@
       </p:sp>
       <p:sp>
         <p:nvSpPr>
-          <p:cNvPr id="8" name="TextBox 7"/>
+          <p:cNvPr id="10" name="TextBox 9"/>
           <p:cNvSpPr txBox="1"/>
           <p:nvPr/>
         </p:nvSpPr>
@@ -7225,7 +7513,7 @@
       </p:sp>
       <p:sp>
         <p:nvSpPr>
-          <p:cNvPr id="9" name="Rounded Rectangle 8"/>
+          <p:cNvPr id="11" name="Rounded Rectangle 10"/>
           <p:cNvSpPr/>
           <p:nvPr/>
         </p:nvSpPr>
@@ -7270,7 +7558,7 @@
       </p:sp>
       <p:sp>
         <p:nvSpPr>
-          <p:cNvPr id="10" name="Rectangle 9"/>
+          <p:cNvPr id="12" name="Rectangle 11"/>
           <p:cNvSpPr/>
           <p:nvPr/>
         </p:nvSpPr>
@@ -7313,7 +7601,7 @@
       </p:sp>
       <p:sp>
         <p:nvSpPr>
-          <p:cNvPr id="11" name="TextBox 10"/>
+          <p:cNvPr id="13" name="TextBox 12"/>
           <p:cNvSpPr txBox="1"/>
           <p:nvPr/>
         </p:nvSpPr>
@@ -7360,7 +7648,7 @@
       </p:sp>
       <p:sp>
         <p:nvSpPr>
-          <p:cNvPr id="12" name="Rounded Rectangle 11"/>
+          <p:cNvPr id="14" name="Rounded Rectangle 13"/>
           <p:cNvSpPr/>
           <p:nvPr/>
         </p:nvSpPr>
@@ -7405,7 +7693,7 @@
       </p:sp>
       <p:sp>
         <p:nvSpPr>
-          <p:cNvPr id="13" name="Rectangle 12"/>
+          <p:cNvPr id="15" name="Rectangle 14"/>
           <p:cNvSpPr/>
           <p:nvPr/>
         </p:nvSpPr>
@@ -7448,7 +7736,7 @@
       </p:sp>
       <p:sp>
         <p:nvSpPr>
-          <p:cNvPr id="14" name="TextBox 13"/>
+          <p:cNvPr id="16" name="TextBox 15"/>
           <p:cNvSpPr txBox="1"/>
           <p:nvPr/>
         </p:nvSpPr>
@@ -7969,9 +8257,57 @@
           </a:p>
         </p:txBody>
       </p:sp>
-      <p:sp>
-        <p:nvSpPr>
-          <p:cNvPr id="6" name="TextBox 5"/>
+      <p:pic>
+        <p:nvPicPr>
+          <p:cNvPr id="6" name="Picture 5" descr="whatsapp.png"/>
+          <p:cNvPicPr>
+            <a:picLocks noChangeAspect="1"/>
+          </p:cNvPicPr>
+          <p:nvPr/>
+        </p:nvPicPr>
+        <p:blipFill>
+          <a:blip r:embed="rId2"/>
+          <a:stretch>
+            <a:fillRect/>
+          </a:stretch>
+        </p:blipFill>
+        <p:spPr>
+          <a:xfrm>
+            <a:off x="4587087" y="1828800"/>
+            <a:ext cx="502920" cy="502920"/>
+          </a:xfrm>
+          <a:prstGeom prst="rect">
+            <a:avLst/>
+          </a:prstGeom>
+        </p:spPr>
+      </p:pic>
+      <p:pic>
+        <p:nvPicPr>
+          <p:cNvPr id="7" name="Picture 6" descr="telegram.png"/>
+          <p:cNvPicPr>
+            <a:picLocks noChangeAspect="1"/>
+          </p:cNvPicPr>
+          <p:nvPr/>
+        </p:nvPicPr>
+        <p:blipFill>
+          <a:blip r:embed="rId3"/>
+          <a:stretch>
+            <a:fillRect/>
+          </a:stretch>
+        </p:blipFill>
+        <p:spPr>
+          <a:xfrm>
+            <a:off x="6233007" y="1828800"/>
+            <a:ext cx="502920" cy="502920"/>
+          </a:xfrm>
+          <a:prstGeom prst="rect">
+            <a:avLst/>
+          </a:prstGeom>
+        </p:spPr>
+      </p:pic>
+      <p:sp>
+        <p:nvSpPr>
+          <p:cNvPr id="8" name="TextBox 7"/>
           <p:cNvSpPr txBox="1"/>
           <p:nvPr/>
         </p:nvSpPr>
@@ -8732,9 +9068,57 @@
           </a:p>
         </p:txBody>
       </p:sp>
-      <p:sp>
-        <p:nvSpPr>
-          <p:cNvPr id="5" name="TextBox 4"/>
+      <p:pic>
+        <p:nvPicPr>
+          <p:cNvPr id="5" name="Picture 4" descr="openai.png"/>
+          <p:cNvPicPr>
+            <a:picLocks noChangeAspect="1"/>
+          </p:cNvPicPr>
+          <p:nvPr/>
+        </p:nvPicPr>
+        <p:blipFill>
+          <a:blip r:embed="rId2"/>
+          <a:stretch>
+            <a:fillRect/>
+          </a:stretch>
+        </p:blipFill>
+        <p:spPr>
+          <a:xfrm>
+            <a:off x="4587087" y="1828800"/>
+            <a:ext cx="502920" cy="502920"/>
+          </a:xfrm>
+          <a:prstGeom prst="rect">
+            <a:avLst/>
+          </a:prstGeom>
+        </p:spPr>
+      </p:pic>
+      <p:pic>
+        <p:nvPicPr>
+          <p:cNvPr id="6" name="Picture 5" descr="issabel.png"/>
+          <p:cNvPicPr>
+            <a:picLocks noChangeAspect="1"/>
+          </p:cNvPicPr>
+          <p:nvPr/>
+        </p:nvPicPr>
+        <p:blipFill>
+          <a:blip r:embed="rId3"/>
+          <a:stretch>
+            <a:fillRect/>
+          </a:stretch>
+        </p:blipFill>
+        <p:spPr>
+          <a:xfrm>
+            <a:off x="6233007" y="1828800"/>
+            <a:ext cx="1760220" cy="502920"/>
+          </a:xfrm>
+          <a:prstGeom prst="rect">
+            <a:avLst/>
+          </a:prstGeom>
+        </p:spPr>
+      </p:pic>
+      <p:sp>
+        <p:nvSpPr>
+          <p:cNvPr id="7" name="TextBox 6"/>
           <p:cNvSpPr txBox="1"/>
           <p:nvPr/>
         </p:nvSpPr>
@@ -9495,9 +9879,81 @@
           </a:p>
         </p:txBody>
       </p:sp>
-      <p:sp>
-        <p:nvSpPr>
-          <p:cNvPr id="5" name="TextBox 4"/>
+      <p:pic>
+        <p:nvPicPr>
+          <p:cNvPr id="5" name="Picture 4" descr="whatsapp.png"/>
+          <p:cNvPicPr>
+            <a:picLocks noChangeAspect="1"/>
+          </p:cNvPicPr>
+          <p:nvPr/>
+        </p:nvPicPr>
+        <p:blipFill>
+          <a:blip r:embed="rId2"/>
+          <a:stretch>
+            <a:fillRect/>
+          </a:stretch>
+        </p:blipFill>
+        <p:spPr>
+          <a:xfrm>
+            <a:off x="3764127" y="1828800"/>
+            <a:ext cx="502920" cy="502920"/>
+          </a:xfrm>
+          <a:prstGeom prst="rect">
+            <a:avLst/>
+          </a:prstGeom>
+        </p:spPr>
+      </p:pic>
+      <p:pic>
+        <p:nvPicPr>
+          <p:cNvPr id="6" name="Picture 5" descr="telegram.png"/>
+          <p:cNvPicPr>
+            <a:picLocks noChangeAspect="1"/>
+          </p:cNvPicPr>
+          <p:nvPr/>
+        </p:nvPicPr>
+        <p:blipFill>
+          <a:blip r:embed="rId3"/>
+          <a:stretch>
+            <a:fillRect/>
+          </a:stretch>
+        </p:blipFill>
+        <p:spPr>
+          <a:xfrm>
+            <a:off x="5410047" y="1828800"/>
+            <a:ext cx="502920" cy="502920"/>
+          </a:xfrm>
+          <a:prstGeom prst="rect">
+            <a:avLst/>
+          </a:prstGeom>
+        </p:spPr>
+      </p:pic>
+      <p:pic>
+        <p:nvPicPr>
+          <p:cNvPr id="7" name="Picture 6" descr="facebook.png"/>
+          <p:cNvPicPr>
+            <a:picLocks noChangeAspect="1"/>
+          </p:cNvPicPr>
+          <p:nvPr/>
+        </p:nvPicPr>
+        <p:blipFill>
+          <a:blip r:embed="rId4"/>
+          <a:stretch>
+            <a:fillRect/>
+          </a:stretch>
+        </p:blipFill>
+        <p:spPr>
+          <a:xfrm>
+            <a:off x="7055967" y="1828800"/>
+            <a:ext cx="502920" cy="502920"/>
+          </a:xfrm>
+          <a:prstGeom prst="rect">
+            <a:avLst/>
+          </a:prstGeom>
+        </p:spPr>
+      </p:pic>
+      <p:sp>
+        <p:nvSpPr>
+          <p:cNvPr id="8" name="TextBox 7"/>
           <p:cNvSpPr txBox="1"/>
           <p:nvPr/>
         </p:nvSpPr>
@@ -10808,9 +11264,81 @@
           </a:p>
         </p:txBody>
       </p:sp>
-      <p:sp>
-        <p:nvSpPr>
-          <p:cNvPr id="5" name="TextBox 4"/>
+      <p:pic>
+        <p:nvPicPr>
+          <p:cNvPr id="5" name="Picture 4" descr="aws.png"/>
+          <p:cNvPicPr>
+            <a:picLocks noChangeAspect="1"/>
+          </p:cNvPicPr>
+          <p:nvPr/>
+        </p:nvPicPr>
+        <p:blipFill>
+          <a:blip r:embed="rId2"/>
+          <a:stretch>
+            <a:fillRect/>
+          </a:stretch>
+        </p:blipFill>
+        <p:spPr>
+          <a:xfrm>
+            <a:off x="3764127" y="1828800"/>
+            <a:ext cx="502920" cy="502920"/>
+          </a:xfrm>
+          <a:prstGeom prst="rect">
+            <a:avLst/>
+          </a:prstGeom>
+        </p:spPr>
+      </p:pic>
+      <p:pic>
+        <p:nvPicPr>
+          <p:cNvPr id="6" name="Picture 5" descr="azure.png"/>
+          <p:cNvPicPr>
+            <a:picLocks noChangeAspect="1"/>
+          </p:cNvPicPr>
+          <p:nvPr/>
+        </p:nvPicPr>
+        <p:blipFill>
+          <a:blip r:embed="rId3"/>
+          <a:stretch>
+            <a:fillRect/>
+          </a:stretch>
+        </p:blipFill>
+        <p:spPr>
+          <a:xfrm>
+            <a:off x="5410047" y="1828800"/>
+            <a:ext cx="502920" cy="502920"/>
+          </a:xfrm>
+          <a:prstGeom prst="rect">
+            <a:avLst/>
+          </a:prstGeom>
+        </p:spPr>
+      </p:pic>
+      <p:pic>
+        <p:nvPicPr>
+          <p:cNvPr id="7" name="Picture 6" descr="gcp.png"/>
+          <p:cNvPicPr>
+            <a:picLocks noChangeAspect="1"/>
+          </p:cNvPicPr>
+          <p:nvPr/>
+        </p:nvPicPr>
+        <p:blipFill>
+          <a:blip r:embed="rId4"/>
+          <a:stretch>
+            <a:fillRect/>
+          </a:stretch>
+        </p:blipFill>
+        <p:spPr>
+          <a:xfrm>
+            <a:off x="7055967" y="1828800"/>
+            <a:ext cx="502920" cy="502920"/>
+          </a:xfrm>
+          <a:prstGeom prst="rect">
+            <a:avLst/>
+          </a:prstGeom>
+        </p:spPr>
+      </p:pic>
+      <p:sp>
+        <p:nvSpPr>
+          <p:cNvPr id="8" name="TextBox 7"/>
           <p:cNvSpPr txBox="1"/>
           <p:nvPr/>
         </p:nvSpPr>
@@ -11927,9 +12455,33 @@
           </a:p>
         </p:txBody>
       </p:sp>
-      <p:sp>
-        <p:nvSpPr>
-          <p:cNvPr id="6" name="TextBox 5"/>
+      <p:pic>
+        <p:nvPicPr>
+          <p:cNvPr id="6" name="Picture 5" descr="zabbix.png"/>
+          <p:cNvPicPr>
+            <a:picLocks noChangeAspect="1"/>
+          </p:cNvPicPr>
+          <p:nvPr/>
+        </p:nvPicPr>
+        <p:blipFill>
+          <a:blip r:embed="rId2"/>
+          <a:stretch>
+            <a:fillRect/>
+          </a:stretch>
+        </p:blipFill>
+        <p:spPr>
+          <a:xfrm>
+            <a:off x="5410047" y="1828800"/>
+            <a:ext cx="1005840" cy="502920"/>
+          </a:xfrm>
+          <a:prstGeom prst="rect">
+            <a:avLst/>
+          </a:prstGeom>
+        </p:spPr>
+      </p:pic>
+      <p:sp>
+        <p:nvSpPr>
+          <p:cNvPr id="7" name="TextBox 6"/>
           <p:cNvSpPr txBox="1"/>
           <p:nvPr/>
         </p:nvSpPr>
@@ -12140,9 +12692,33 @@
           </a:p>
         </p:txBody>
       </p:sp>
-      <p:sp>
-        <p:nvSpPr>
-          <p:cNvPr id="5" name="Rounded Rectangle 4"/>
+      <p:pic>
+        <p:nvPicPr>
+          <p:cNvPr id="5" name="Picture 4" descr="zabbix.png"/>
+          <p:cNvPicPr>
+            <a:picLocks noChangeAspect="1"/>
+          </p:cNvPicPr>
+          <p:nvPr/>
+        </p:nvPicPr>
+        <p:blipFill>
+          <a:blip r:embed="rId2"/>
+          <a:stretch>
+            <a:fillRect/>
+          </a:stretch>
+        </p:blipFill>
+        <p:spPr>
+          <a:xfrm>
+            <a:off x="5410047" y="1417320"/>
+            <a:ext cx="1005840" cy="502920"/>
+          </a:xfrm>
+          <a:prstGeom prst="rect">
+            <a:avLst/>
+          </a:prstGeom>
+        </p:spPr>
+      </p:pic>
+      <p:sp>
+        <p:nvSpPr>
+          <p:cNvPr id="6" name="Rounded Rectangle 5"/>
           <p:cNvSpPr/>
           <p:nvPr/>
         </p:nvSpPr>
@@ -12187,7 +12763,7 @@
       </p:sp>
       <p:sp>
         <p:nvSpPr>
-          <p:cNvPr id="6" name="Rectangle 5"/>
+          <p:cNvPr id="7" name="Rectangle 6"/>
           <p:cNvSpPr/>
           <p:nvPr/>
         </p:nvSpPr>
@@ -12230,7 +12806,7 @@
       </p:sp>
       <p:sp>
         <p:nvSpPr>
-          <p:cNvPr id="7" name="TextBox 6"/>
+          <p:cNvPr id="8" name="TextBox 7"/>
           <p:cNvSpPr txBox="1"/>
           <p:nvPr/>
         </p:nvSpPr>
@@ -12277,7 +12853,7 @@
       </p:sp>
       <p:sp>
         <p:nvSpPr>
-          <p:cNvPr id="8" name="Rounded Rectangle 7"/>
+          <p:cNvPr id="9" name="Rounded Rectangle 8"/>
           <p:cNvSpPr/>
           <p:nvPr/>
         </p:nvSpPr>
@@ -12322,7 +12898,7 @@
       </p:sp>
       <p:sp>
         <p:nvSpPr>
-          <p:cNvPr id="9" name="Rectangle 8"/>
+          <p:cNvPr id="10" name="Rectangle 9"/>
           <p:cNvSpPr/>
           <p:nvPr/>
         </p:nvSpPr>
@@ -12365,7 +12941,7 @@
       </p:sp>
       <p:sp>
         <p:nvSpPr>
-          <p:cNvPr id="10" name="TextBox 9"/>
+          <p:cNvPr id="11" name="TextBox 10"/>
           <p:cNvSpPr txBox="1"/>
           <p:nvPr/>
         </p:nvSpPr>
@@ -12412,7 +12988,7 @@
       </p:sp>
       <p:sp>
         <p:nvSpPr>
-          <p:cNvPr id="11" name="Rounded Rectangle 10"/>
+          <p:cNvPr id="12" name="Rounded Rectangle 11"/>
           <p:cNvSpPr/>
           <p:nvPr/>
         </p:nvSpPr>
@@ -12457,7 +13033,7 @@
       </p:sp>
       <p:sp>
         <p:nvSpPr>
-          <p:cNvPr id="12" name="Rectangle 11"/>
+          <p:cNvPr id="13" name="Rectangle 12"/>
           <p:cNvSpPr/>
           <p:nvPr/>
         </p:nvSpPr>
@@ -12500,7 +13076,7 @@
       </p:sp>
       <p:sp>
         <p:nvSpPr>
-          <p:cNvPr id="13" name="TextBox 12"/>
+          <p:cNvPr id="14" name="TextBox 13"/>
           <p:cNvSpPr txBox="1"/>
           <p:nvPr/>
         </p:nvSpPr>
@@ -13571,9 +14147,33 @@
           </a:p>
         </p:txBody>
       </p:sp>
-      <p:sp>
-        <p:nvSpPr>
-          <p:cNvPr id="6" name="TextBox 5"/>
+      <p:pic>
+        <p:nvPicPr>
+          <p:cNvPr id="6" name="Picture 5" descr="otobo.png"/>
+          <p:cNvPicPr>
+            <a:picLocks noChangeAspect="1"/>
+          </p:cNvPicPr>
+          <p:nvPr/>
+        </p:nvPicPr>
+        <p:blipFill>
+          <a:blip r:embed="rId2"/>
+          <a:stretch>
+            <a:fillRect/>
+          </a:stretch>
+        </p:blipFill>
+        <p:spPr>
+          <a:xfrm>
+            <a:off x="5410047" y="1828800"/>
+            <a:ext cx="1760220" cy="502920"/>
+          </a:xfrm>
+          <a:prstGeom prst="rect">
+            <a:avLst/>
+          </a:prstGeom>
+        </p:spPr>
+      </p:pic>
+      <p:sp>
+        <p:nvSpPr>
+          <p:cNvPr id="7" name="TextBox 6"/>
           <p:cNvSpPr txBox="1"/>
           <p:nvPr/>
         </p:nvSpPr>

</xml_diff>